<commit_message>
??????????? ?????? ?????: ?????? ??????????? ? ?????? ??????
</commit_message>
<xml_diff>
--- a/prezentacii/Karl-Linney-temnaya.pptx
+++ b/prezentacii/Karl-Linney-temnaya.pptx
@@ -101,7 +101,7 @@
         </p:nvSpPr>
         <p:spPr>
           <a:xfrm>
-            <a:off x="765175" y="1197372"/>
+            <a:off x="765175" y="1003697"/>
             <a:ext cx="1945680" cy="269875"/>
           </a:xfrm>
           <a:prstGeom prst="roundRect">
@@ -128,7 +128,7 @@
         </p:nvSpPr>
         <p:spPr>
           <a:xfrm>
-            <a:off x="996950" y="1229122"/>
+            <a:off x="996950" y="1035447"/>
             <a:ext cx="1609130" cy="161925"/>
           </a:xfrm>
           <a:prstGeom prst="rect">
@@ -177,7 +177,7 @@
         </p:nvSpPr>
         <p:spPr>
           <a:xfrm>
-            <a:off x="869950" y="1306909"/>
+            <a:off x="869950" y="1113234"/>
             <a:ext cx="50800" cy="50800"/>
           </a:xfrm>
           <a:prstGeom prst="ellipse">
@@ -204,7 +204,7 @@
         </p:nvSpPr>
         <p:spPr>
           <a:xfrm>
-            <a:off x="762000" y="1727002"/>
+            <a:off x="762000" y="1533327"/>
             <a:ext cx="5400377" cy="1226741"/>
           </a:xfrm>
           <a:prstGeom prst="rect">
@@ -267,7 +267,7 @@
         </p:nvSpPr>
         <p:spPr>
           <a:xfrm>
-            <a:off x="762000" y="3040063"/>
+            <a:off x="762000" y="2846388"/>
             <a:ext cx="4559796" cy="228600"/>
           </a:xfrm>
           <a:prstGeom prst="rect">
@@ -310,13 +310,62 @@
       </p:sp>
       <p:sp>
         <p:nvSpPr>
-          <p:cNvPr id="7" name="Rounded Rectangle"/>
+          <p:cNvPr id="7" name="Text: Выполнила: Самушенко Вероника, ученица 5"/>
+          <p:cNvSpPr txBox="1"/>
+          <p:nvPr/>
+        </p:nvSpPr>
+        <p:spPr>
+          <a:xfrm>
+            <a:off x="762000" y="3252788"/>
+            <a:ext cx="3388122" cy="209550"/>
+          </a:xfrm>
+          <a:prstGeom prst="rect">
+            <a:avLst/>
+          </a:prstGeom>
+          <a:noFill/>
+        </p:spPr>
+        <p:txBody>
+          <a:bodyPr wrap="none" lIns="0" tIns="0" rIns="0" bIns="0" rtlCol="0" anchor="t">
+            <a:noAutofit/>
+          </a:bodyPr>
+          <a:lstStyle/>
+          <a:p>
+            <a:pPr algn="l">
+              <a:lnSpc>
+                <a:spcPts val="1650"/>
+              </a:lnSpc>
+              <a:spcBef>
+                <a:spcPts val="0"/>
+              </a:spcBef>
+              <a:spcAft>
+                <a:spcPts val="0"/>
+              </a:spcAft>
+              <a:buNone/>
+            </a:pPr>
+            <a:r>
+              <a:rPr lang="en-US" sz="1100" spc="-4" dirty="0">
+                <a:solidFill>
+                  <a:srgbClr val="F5F5F5"/>
+                </a:solidFill>
+                <a:latin typeface="Segoe UI"/>
+                <a:ea typeface="Segoe UI"/>
+                <a:cs typeface="Segoe UI"/>
+              </a:rPr>
+              <a:t>Выполнила: Самушенко Вероника, ученица 5г класса</a:t>
+            </a:r>
+            <a:endParaRPr lang="en-US" sz="1100" dirty="0"/>
+          </a:p>
+        </p:txBody>
+      </p:sp>
+      <p:sp>
+        <p:nvSpPr>
+          <p:cNvPr id="8" name="Rounded Rectangle"/>
           <p:cNvSpPr/>
           <p:nvPr/>
         </p:nvSpPr>
         <p:spPr>
           <a:xfrm>
-            <a:off x="765175" y="3462338"/>
+            <a:off x="765175" y="3656013"/>
             <a:ext cx="1771650" cy="2198291"/>
           </a:xfrm>
           <a:prstGeom prst="roundRect">
@@ -335,7 +384,7 @@
       </p:sp>
       <p:pic>
         <p:nvPicPr>
-          <p:cNvPr id="8" name="Image: Портрет Карла Линнея"/>
+          <p:cNvPr id="9" name="Image: Портрет Карла Линнея"/>
           <p:cNvPicPr>
             <a:picLocks noChangeAspect="1"/>
           </p:cNvPicPr>
@@ -350,7 +399,7 @@
         </p:blipFill>
         <p:spPr>
           <a:xfrm>
-            <a:off x="768350" y="3465513"/>
+            <a:off x="768350" y="3659188"/>
             <a:ext cx="1765300" cy="2191941"/>
           </a:xfrm>
           <a:prstGeom prst="rect">
@@ -363,7 +412,7 @@
       </p:pic>
       <p:pic>
         <p:nvPicPr>
-          <p:cNvPr id="9" name="Rendered image"/>
+          <p:cNvPr id="10" name="Rendered image"/>
           <p:cNvPicPr>
             <a:picLocks noChangeAspect="1"/>
           </p:cNvPicPr>
@@ -3254,7 +3303,7 @@
         </p:nvSpPr>
         <p:spPr>
           <a:xfrm>
-            <a:off x="765175" y="1216422"/>
+            <a:off x="765175" y="1029097"/>
             <a:ext cx="643136" cy="269875"/>
           </a:xfrm>
           <a:prstGeom prst="roundRect">
@@ -3281,7 +3330,7 @@
         </p:nvSpPr>
         <p:spPr>
           <a:xfrm>
-            <a:off x="996950" y="1248172"/>
+            <a:off x="996950" y="1060847"/>
             <a:ext cx="306586" cy="161925"/>
           </a:xfrm>
           <a:prstGeom prst="rect">
@@ -3330,7 +3379,7 @@
         </p:nvSpPr>
         <p:spPr>
           <a:xfrm>
-            <a:off x="869950" y="1325959"/>
+            <a:off x="869950" y="1138634"/>
             <a:ext cx="50800" cy="50800"/>
           </a:xfrm>
           <a:prstGeom prst="ellipse">
@@ -3357,7 +3406,7 @@
         </p:nvSpPr>
         <p:spPr>
           <a:xfrm>
-            <a:off x="4327922" y="1733352"/>
+            <a:off x="4327922" y="1546027"/>
             <a:ext cx="3536156" cy="1226741"/>
           </a:xfrm>
           <a:prstGeom prst="rect">
@@ -3420,7 +3469,7 @@
         </p:nvSpPr>
         <p:spPr>
           <a:xfrm>
-            <a:off x="3901480" y="3033713"/>
+            <a:off x="3901480" y="2846388"/>
             <a:ext cx="4389041" cy="228600"/>
           </a:xfrm>
           <a:prstGeom prst="rect">
@@ -3463,13 +3512,62 @@
       </p:sp>
       <p:sp>
         <p:nvSpPr>
-          <p:cNvPr id="7" name="Rounded Rectangle"/>
+          <p:cNvPr id="7" name="Text: Выполнила: Самушенко Вероника, ученица 5"/>
+          <p:cNvSpPr txBox="1"/>
+          <p:nvPr/>
+        </p:nvSpPr>
+        <p:spPr>
+          <a:xfrm>
+            <a:off x="4401939" y="3240088"/>
+            <a:ext cx="3388122" cy="209550"/>
+          </a:xfrm>
+          <a:prstGeom prst="rect">
+            <a:avLst/>
+          </a:prstGeom>
+          <a:noFill/>
+        </p:spPr>
+        <p:txBody>
+          <a:bodyPr wrap="none" lIns="0" tIns="0" rIns="0" bIns="0" rtlCol="0" anchor="t">
+            <a:noAutofit/>
+          </a:bodyPr>
+          <a:lstStyle/>
+          <a:p>
+            <a:pPr algn="ctr">
+              <a:lnSpc>
+                <a:spcPts val="1650"/>
+              </a:lnSpc>
+              <a:spcBef>
+                <a:spcPts val="0"/>
+              </a:spcBef>
+              <a:spcAft>
+                <a:spcPts val="0"/>
+              </a:spcAft>
+              <a:buNone/>
+            </a:pPr>
+            <a:r>
+              <a:rPr lang="en-US" sz="1100" spc="-4" dirty="0">
+                <a:solidFill>
+                  <a:srgbClr val="F5F5F5"/>
+                </a:solidFill>
+                <a:latin typeface="Segoe UI"/>
+                <a:ea typeface="Segoe UI"/>
+                <a:cs typeface="Segoe UI"/>
+              </a:rPr>
+              <a:t>Выполнила: Самушенко Вероника, ученица 5г класса</a:t>
+            </a:r>
+            <a:endParaRPr lang="en-US" sz="1100" dirty="0"/>
+          </a:p>
+        </p:txBody>
+      </p:sp>
+      <p:sp>
+        <p:nvSpPr>
+          <p:cNvPr id="8" name="Rounded Rectangle"/>
           <p:cNvSpPr/>
           <p:nvPr/>
         </p:nvSpPr>
         <p:spPr>
           <a:xfrm>
-            <a:off x="5210175" y="3443288"/>
+            <a:off x="5210175" y="3630613"/>
             <a:ext cx="1771650" cy="2198291"/>
           </a:xfrm>
           <a:prstGeom prst="roundRect">
@@ -3488,7 +3586,7 @@
       </p:sp>
       <p:pic>
         <p:nvPicPr>
-          <p:cNvPr id="8" name="Image: Портрет Линнея"/>
+          <p:cNvPr id="9" name="Image: Портрет Линнея"/>
           <p:cNvPicPr>
             <a:picLocks noChangeAspect="1"/>
           </p:cNvPicPr>
@@ -3503,7 +3601,7 @@
         </p:blipFill>
         <p:spPr>
           <a:xfrm>
-            <a:off x="5213350" y="3446463"/>
+            <a:off x="5213350" y="3633788"/>
             <a:ext cx="1765300" cy="2191941"/>
           </a:xfrm>
           <a:prstGeom prst="rect">
@@ -3516,7 +3614,7 @@
       </p:pic>
       <p:pic>
         <p:nvPicPr>
-          <p:cNvPr id="9" name="Rendered image"/>
+          <p:cNvPr id="10" name="Rendered image"/>
           <p:cNvPicPr>
             <a:picLocks noChangeAspect="1"/>
           </p:cNvPicPr>

</xml_diff>